<commit_message>
Fixed ppt generation with all the required imformation
</commit_message>
<xml_diff>
--- a/HP_Proposal_Professional.pptx
+++ b/HP_Proposal_Professional.pptx
@@ -15,6 +15,7 @@
     <p:sldId id="263" r:id="rId14"/>
     <p:sldId id="264" r:id="rId15"/>
     <p:sldId id="265" r:id="rId16"/>
+    <p:sldId id="266" r:id="rId17"/>
   </p:sldIdLst>
   <p:sldSz cx="9144000" cy="6858000" type="screen4x3"/>
   <p:notesSz cx="6858000" cy="9144000"/>
@@ -3105,8 +3106,8 @@
         </p:nvSpPr>
         <p:spPr>
           <a:xfrm>
-            <a:off x="914400" y="1828800"/>
-            <a:ext cx="7315200" cy="1828800"/>
+            <a:off x="914400" y="457200"/>
+            <a:ext cx="7315200" cy="5486400"/>
           </a:xfrm>
           <a:prstGeom prst="rect">
             <a:avLst/>
@@ -3120,14 +3121,14 @@
           <a:lstStyle/>
           <a:p>
             <a:pPr algn="ctr">
-              <a:defRPr b="1" sz="3400">
+              <a:defRPr b="1" sz="3000">
                 <a:solidFill>
                   <a:srgbClr val="004279"/>
                 </a:solidFill>
               </a:defRPr>
             </a:pPr>
             <a:r>
-              <a:t>Introducing the HP ProBook and EliteBook series, combining sleek, lightweight designs with robust performance tailored for professionals. Experience upgradeable RAM and powerful Intel® or AMD technology, ensuring seamless multitasking and reliable performance. With impressive displays and extensive connectivity options, these laptops are perfect for enhancing productivity in any work environment. Elevate your business capabilities with the security and reliability your team deserves.</a:t>
+              <a:t>Introducing the HP ProBook and EliteBook series, designed for the modern business professional. With lightweight designs and upgradeable RAM up to 16 GB, these laptops provide exceptional performance and portability. Optimize your productivity with tailored configurations, including discrete graphics and robust security features. Elevate your work experience with reliable performance on Windows 8 Pro, empowering you to tackle any task with confidence.</a:t>
             </a:r>
           </a:p>
         </p:txBody>
@@ -3193,6 +3194,595 @@
         </p:nvSpPr>
         <p:spPr>
           <a:xfrm>
+            <a:off x="457200" y="182880"/>
+            <a:ext cx="8229600" cy="548640"/>
+          </a:xfrm>
+          <a:prstGeom prst="rect">
+            <a:avLst/>
+          </a:prstGeom>
+          <a:noFill/>
+        </p:spPr>
+        <p:txBody>
+          <a:bodyPr wrap="none">
+            <a:spAutoFit/>
+          </a:bodyPr>
+          <a:lstStyle/>
+          <a:p>
+            <a:pPr>
+              <a:defRPr sz="2800" b="1"/>
+            </a:pPr>
+            <a:r>
+              <a:t>Upsell Recommendations — Page 2</a:t>
+            </a:r>
+          </a:p>
+        </p:txBody>
+      </p:sp>
+      <p:sp>
+        <p:nvSpPr>
+          <p:cNvPr id="3" name="TextBox 2"/>
+          <p:cNvSpPr txBox="1"/>
+          <p:nvPr/>
+        </p:nvSpPr>
+        <p:spPr>
+          <a:xfrm>
+            <a:off x="457200" y="1097280"/>
+            <a:ext cx="2743200" cy="365760"/>
+          </a:xfrm>
+          <a:prstGeom prst="rect">
+            <a:avLst/>
+          </a:prstGeom>
+          <a:noFill/>
+        </p:spPr>
+        <p:txBody>
+          <a:bodyPr wrap="square">
+            <a:spAutoFit/>
+          </a:bodyPr>
+          <a:lstStyle/>
+          <a:p>
+            <a:pPr algn="ctr">
+              <a:defRPr sz="2200" b="1">
+                <a:solidFill>
+                  <a:srgbClr val="000000"/>
+                </a:solidFill>
+              </a:defRPr>
+            </a:pPr>
+            <a:r>
+              <a:t>Sleeve</a:t>
+            </a:r>
+          </a:p>
+        </p:txBody>
+      </p:sp>
+      <p:pic>
+        <p:nvPicPr>
+          <p:cNvPr id="4" name="Picture 3" descr="page_28_img_9.png"/>
+          <p:cNvPicPr>
+            <a:picLocks noChangeAspect="1"/>
+          </p:cNvPicPr>
+          <p:nvPr/>
+        </p:nvPicPr>
+        <p:blipFill>
+          <a:blip r:embed="rId2"/>
+          <a:stretch>
+            <a:fillRect/>
+          </a:stretch>
+        </p:blipFill>
+        <p:spPr>
+          <a:xfrm>
+            <a:off x="1272487" y="1463040"/>
+            <a:ext cx="1112626" cy="914400"/>
+          </a:xfrm>
+          <a:prstGeom prst="rect">
+            <a:avLst/>
+          </a:prstGeom>
+        </p:spPr>
+      </p:pic>
+      <p:sp>
+        <p:nvSpPr>
+          <p:cNvPr id="5" name="TextBox 4"/>
+          <p:cNvSpPr txBox="1"/>
+          <p:nvPr/>
+        </p:nvSpPr>
+        <p:spPr>
+          <a:xfrm>
+            <a:off x="457200" y="2377440"/>
+            <a:ext cx="2743200" cy="329184"/>
+          </a:xfrm>
+          <a:prstGeom prst="rect">
+            <a:avLst/>
+          </a:prstGeom>
+          <a:noFill/>
+        </p:spPr>
+        <p:txBody>
+          <a:bodyPr wrap="square">
+            <a:spAutoFit/>
+          </a:bodyPr>
+          <a:lstStyle/>
+          <a:p>
+            <a:pPr algn="ctr">
+              <a:defRPr sz="1400" b="1">
+                <a:solidFill>
+                  <a:srgbClr val="000000"/>
+                </a:solidFill>
+              </a:defRPr>
+            </a:pPr>
+            <a:r>
+              <a:t>HP ElitePad Case</a:t>
+            </a:r>
+          </a:p>
+        </p:txBody>
+      </p:sp>
+      <p:sp>
+        <p:nvSpPr>
+          <p:cNvPr id="6" name="TextBox 5"/>
+          <p:cNvSpPr txBox="1"/>
+          <p:nvPr/>
+        </p:nvSpPr>
+        <p:spPr>
+          <a:xfrm>
+            <a:off x="457200" y="2706624"/>
+            <a:ext cx="2743200" cy="585216"/>
+          </a:xfrm>
+          <a:prstGeom prst="rect">
+            <a:avLst/>
+          </a:prstGeom>
+          <a:noFill/>
+        </p:spPr>
+        <p:txBody>
+          <a:bodyPr wrap="square">
+            <a:spAutoFit/>
+          </a:bodyPr>
+          <a:lstStyle/>
+          <a:p>
+            <a:pPr algn="l">
+              <a:defRPr sz="1100" b="0">
+                <a:solidFill>
+                  <a:srgbClr val="000000"/>
+                </a:solidFill>
+              </a:defRPr>
+            </a:pPr>
+            <a:r>
+              <a:t>Sophistication. Durability. We've got you covered. Carry your HP Elite</a:t>
+            </a:r>
+          </a:p>
+        </p:txBody>
+      </p:sp>
+      <p:pic>
+        <p:nvPicPr>
+          <p:cNvPr id="7" name="Picture 6" descr="page_28_img_9.png"/>
+          <p:cNvPicPr>
+            <a:picLocks noChangeAspect="1"/>
+          </p:cNvPicPr>
+          <p:nvPr/>
+        </p:nvPicPr>
+        <p:blipFill>
+          <a:blip r:embed="rId2"/>
+          <a:stretch>
+            <a:fillRect/>
+          </a:stretch>
+        </p:blipFill>
+        <p:spPr>
+          <a:xfrm>
+            <a:off x="1272487" y="3291840"/>
+            <a:ext cx="1112626" cy="914400"/>
+          </a:xfrm>
+          <a:prstGeom prst="rect">
+            <a:avLst/>
+          </a:prstGeom>
+        </p:spPr>
+      </p:pic>
+      <p:sp>
+        <p:nvSpPr>
+          <p:cNvPr id="8" name="TextBox 7"/>
+          <p:cNvSpPr txBox="1"/>
+          <p:nvPr/>
+        </p:nvSpPr>
+        <p:spPr>
+          <a:xfrm>
+            <a:off x="457200" y="4206240"/>
+            <a:ext cx="2743200" cy="329184"/>
+          </a:xfrm>
+          <a:prstGeom prst="rect">
+            <a:avLst/>
+          </a:prstGeom>
+          <a:noFill/>
+        </p:spPr>
+        <p:txBody>
+          <a:bodyPr wrap="square">
+            <a:spAutoFit/>
+          </a:bodyPr>
+          <a:lstStyle/>
+          <a:p>
+            <a:pPr algn="ctr">
+              <a:defRPr sz="1400" b="1">
+                <a:solidFill>
+                  <a:srgbClr val="000000"/>
+                </a:solidFill>
+              </a:defRPr>
+            </a:pPr>
+            <a:r>
+              <a:t>HP ElitePad Rugged Case</a:t>
+            </a:r>
+          </a:p>
+        </p:txBody>
+      </p:sp>
+      <p:sp>
+        <p:nvSpPr>
+          <p:cNvPr id="9" name="TextBox 8"/>
+          <p:cNvSpPr txBox="1"/>
+          <p:nvPr/>
+        </p:nvSpPr>
+        <p:spPr>
+          <a:xfrm>
+            <a:off x="457200" y="4535424"/>
+            <a:ext cx="2743200" cy="585216"/>
+          </a:xfrm>
+          <a:prstGeom prst="rect">
+            <a:avLst/>
+          </a:prstGeom>
+          <a:noFill/>
+        </p:spPr>
+        <p:txBody>
+          <a:bodyPr wrap="square">
+            <a:spAutoFit/>
+          </a:bodyPr>
+          <a:lstStyle/>
+          <a:p>
+            <a:pPr algn="l">
+              <a:defRPr sz="1100" b="0">
+                <a:solidFill>
+                  <a:srgbClr val="000000"/>
+                </a:solidFill>
+              </a:defRPr>
+            </a:pPr>
+            <a:r>
+              <a:t>Help protect your HP ElitePad when you work with a business rugged env</a:t>
+            </a:r>
+          </a:p>
+        </p:txBody>
+      </p:sp>
+      <p:sp>
+        <p:nvSpPr>
+          <p:cNvPr id="10" name="TextBox 9"/>
+          <p:cNvSpPr txBox="1"/>
+          <p:nvPr/>
+        </p:nvSpPr>
+        <p:spPr>
+          <a:xfrm>
+            <a:off x="3200400" y="1097280"/>
+            <a:ext cx="2743200" cy="365760"/>
+          </a:xfrm>
+          <a:prstGeom prst="rect">
+            <a:avLst/>
+          </a:prstGeom>
+          <a:noFill/>
+        </p:spPr>
+        <p:txBody>
+          <a:bodyPr wrap="square">
+            <a:spAutoFit/>
+          </a:bodyPr>
+          <a:lstStyle/>
+          <a:p>
+            <a:pPr algn="ctr">
+              <a:defRPr sz="2200" b="1">
+                <a:solidFill>
+                  <a:srgbClr val="000000"/>
+                </a:solidFill>
+              </a:defRPr>
+            </a:pPr>
+            <a:r>
+              <a:t>Docking Station</a:t>
+            </a:r>
+          </a:p>
+        </p:txBody>
+      </p:sp>
+      <p:pic>
+        <p:nvPicPr>
+          <p:cNvPr id="11" name="Picture 10" descr="page_28_img_4.png"/>
+          <p:cNvPicPr>
+            <a:picLocks noChangeAspect="1"/>
+          </p:cNvPicPr>
+          <p:nvPr/>
+        </p:nvPicPr>
+        <p:blipFill>
+          <a:blip r:embed="rId3"/>
+          <a:stretch>
+            <a:fillRect/>
+          </a:stretch>
+        </p:blipFill>
+        <p:spPr>
+          <a:xfrm>
+            <a:off x="3863009" y="1463040"/>
+            <a:ext cx="1417982" cy="914400"/>
+          </a:xfrm>
+          <a:prstGeom prst="rect">
+            <a:avLst/>
+          </a:prstGeom>
+        </p:spPr>
+      </p:pic>
+      <p:sp>
+        <p:nvSpPr>
+          <p:cNvPr id="12" name="TextBox 11"/>
+          <p:cNvSpPr txBox="1"/>
+          <p:nvPr/>
+        </p:nvSpPr>
+        <p:spPr>
+          <a:xfrm>
+            <a:off x="3200400" y="2377440"/>
+            <a:ext cx="2743200" cy="329184"/>
+          </a:xfrm>
+          <a:prstGeom prst="rect">
+            <a:avLst/>
+          </a:prstGeom>
+          <a:noFill/>
+        </p:spPr>
+        <p:txBody>
+          <a:bodyPr wrap="square">
+            <a:spAutoFit/>
+          </a:bodyPr>
+          <a:lstStyle/>
+          <a:p>
+            <a:pPr algn="ctr">
+              <a:defRPr sz="1400" b="1">
+                <a:solidFill>
+                  <a:srgbClr val="000000"/>
+                </a:solidFill>
+              </a:defRPr>
+            </a:pPr>
+            <a:r>
+              <a:t>HP 2012 230W Docking Station</a:t>
+            </a:r>
+          </a:p>
+        </p:txBody>
+      </p:sp>
+      <p:sp>
+        <p:nvSpPr>
+          <p:cNvPr id="13" name="TextBox 12"/>
+          <p:cNvSpPr txBox="1"/>
+          <p:nvPr/>
+        </p:nvSpPr>
+        <p:spPr>
+          <a:xfrm>
+            <a:off x="3200400" y="2706624"/>
+            <a:ext cx="2743200" cy="585216"/>
+          </a:xfrm>
+          <a:prstGeom prst="rect">
+            <a:avLst/>
+          </a:prstGeom>
+          <a:noFill/>
+        </p:spPr>
+        <p:txBody>
+          <a:bodyPr wrap="square">
+            <a:spAutoFit/>
+          </a:bodyPr>
+          <a:lstStyle/>
+          <a:p>
+            <a:pPr algn="l">
+              <a:defRPr sz="1100" b="0">
+                <a:solidFill>
+                  <a:srgbClr val="000000"/>
+                </a:solidFill>
+              </a:defRPr>
+            </a:pPr>
+            <a:r>
+              <a:t>HP offers a full line of docking stations designed exclusively for sel</a:t>
+            </a:r>
+          </a:p>
+        </p:txBody>
+      </p:sp>
+      <p:pic>
+        <p:nvPicPr>
+          <p:cNvPr id="14" name="Picture 13" descr="page_28_img_4.png"/>
+          <p:cNvPicPr>
+            <a:picLocks noChangeAspect="1"/>
+          </p:cNvPicPr>
+          <p:nvPr/>
+        </p:nvPicPr>
+        <p:blipFill>
+          <a:blip r:embed="rId3"/>
+          <a:stretch>
+            <a:fillRect/>
+          </a:stretch>
+        </p:blipFill>
+        <p:spPr>
+          <a:xfrm>
+            <a:off x="3863009" y="3291840"/>
+            <a:ext cx="1417982" cy="914400"/>
+          </a:xfrm>
+          <a:prstGeom prst="rect">
+            <a:avLst/>
+          </a:prstGeom>
+        </p:spPr>
+      </p:pic>
+      <p:sp>
+        <p:nvSpPr>
+          <p:cNvPr id="15" name="TextBox 14"/>
+          <p:cNvSpPr txBox="1"/>
+          <p:nvPr/>
+        </p:nvSpPr>
+        <p:spPr>
+          <a:xfrm>
+            <a:off x="3200400" y="4206240"/>
+            <a:ext cx="2743200" cy="329184"/>
+          </a:xfrm>
+          <a:prstGeom prst="rect">
+            <a:avLst/>
+          </a:prstGeom>
+          <a:noFill/>
+        </p:spPr>
+        <p:txBody>
+          <a:bodyPr wrap="square">
+            <a:spAutoFit/>
+          </a:bodyPr>
+          <a:lstStyle/>
+          <a:p>
+            <a:pPr algn="ctr">
+              <a:defRPr sz="1400" b="1">
+                <a:solidFill>
+                  <a:srgbClr val="000000"/>
+                </a:solidFill>
+              </a:defRPr>
+            </a:pPr>
+            <a:r>
+              <a:t>HP 2012 230W Advanced Docking Station</a:t>
+            </a:r>
+          </a:p>
+        </p:txBody>
+      </p:sp>
+      <p:sp>
+        <p:nvSpPr>
+          <p:cNvPr id="16" name="TextBox 15"/>
+          <p:cNvSpPr txBox="1"/>
+          <p:nvPr/>
+        </p:nvSpPr>
+        <p:spPr>
+          <a:xfrm>
+            <a:off x="3200400" y="4535424"/>
+            <a:ext cx="2743200" cy="585216"/>
+          </a:xfrm>
+          <a:prstGeom prst="rect">
+            <a:avLst/>
+          </a:prstGeom>
+          <a:noFill/>
+        </p:spPr>
+        <p:txBody>
+          <a:bodyPr wrap="square">
+            <a:spAutoFit/>
+          </a:bodyPr>
+          <a:lstStyle/>
+          <a:p>
+            <a:pPr algn="l">
+              <a:defRPr sz="1100" b="0">
+                <a:solidFill>
+                  <a:srgbClr val="000000"/>
+                </a:solidFill>
+              </a:defRPr>
+            </a:pPr>
+            <a:r>
+              <a:t>HP offers a full line of docking stations designed exclusively for sel</a:t>
+            </a:r>
+          </a:p>
+        </p:txBody>
+      </p:sp>
+      <p:pic>
+        <p:nvPicPr>
+          <p:cNvPr id="17" name="Picture 16" descr="page_28_img_3.png"/>
+          <p:cNvPicPr>
+            <a:picLocks noChangeAspect="1"/>
+          </p:cNvPicPr>
+          <p:nvPr/>
+        </p:nvPicPr>
+        <p:blipFill>
+          <a:blip r:embed="rId4"/>
+          <a:stretch>
+            <a:fillRect/>
+          </a:stretch>
+        </p:blipFill>
+        <p:spPr>
+          <a:xfrm>
+            <a:off x="3845257" y="5120640"/>
+            <a:ext cx="1453486" cy="914400"/>
+          </a:xfrm>
+          <a:prstGeom prst="rect">
+            <a:avLst/>
+          </a:prstGeom>
+        </p:spPr>
+      </p:pic>
+      <p:sp>
+        <p:nvSpPr>
+          <p:cNvPr id="18" name="TextBox 17"/>
+          <p:cNvSpPr txBox="1"/>
+          <p:nvPr/>
+        </p:nvSpPr>
+        <p:spPr>
+          <a:xfrm>
+            <a:off x="3200400" y="6035040"/>
+            <a:ext cx="2743200" cy="329184"/>
+          </a:xfrm>
+          <a:prstGeom prst="rect">
+            <a:avLst/>
+          </a:prstGeom>
+          <a:noFill/>
+        </p:spPr>
+        <p:txBody>
+          <a:bodyPr wrap="square">
+            <a:spAutoFit/>
+          </a:bodyPr>
+          <a:lstStyle/>
+          <a:p>
+            <a:pPr algn="ctr">
+              <a:defRPr sz="1400" b="1">
+                <a:solidFill>
+                  <a:srgbClr val="000000"/>
+                </a:solidFill>
+              </a:defRPr>
+            </a:pPr>
+            <a:r>
+              <a:t>HP 2012 120W Advanced Docking Station</a:t>
+            </a:r>
+          </a:p>
+        </p:txBody>
+      </p:sp>
+      <p:sp>
+        <p:nvSpPr>
+          <p:cNvPr id="19" name="TextBox 18"/>
+          <p:cNvSpPr txBox="1"/>
+          <p:nvPr/>
+        </p:nvSpPr>
+        <p:spPr>
+          <a:xfrm>
+            <a:off x="3200400" y="6364224"/>
+            <a:ext cx="2743200" cy="585216"/>
+          </a:xfrm>
+          <a:prstGeom prst="rect">
+            <a:avLst/>
+          </a:prstGeom>
+          <a:noFill/>
+        </p:spPr>
+        <p:txBody>
+          <a:bodyPr wrap="square">
+            <a:spAutoFit/>
+          </a:bodyPr>
+          <a:lstStyle/>
+          <a:p>
+            <a:pPr algn="l">
+              <a:defRPr sz="1100" b="0">
+                <a:solidFill>
+                  <a:srgbClr val="000000"/>
+                </a:solidFill>
+              </a:defRPr>
+            </a:pPr>
+            <a:r>
+              <a:t>HP offers a full line of docking stations designed exclusively for sel</a:t>
+            </a:r>
+          </a:p>
+        </p:txBody>
+      </p:sp>
+    </p:spTree>
+  </p:cSld>
+  <p:clrMapOvr>
+    <a:masterClrMapping/>
+  </p:clrMapOvr>
+</p:sld>
+</file>
+
+<file path=ppt/slides/slide11.xml><?xml version="1.0" encoding="utf-8"?>
+<p:sld xmlns:a="http://schemas.openxmlformats.org/drawingml/2006/main" xmlns:p="http://schemas.openxmlformats.org/presentationml/2006/main" xmlns:r="http://schemas.openxmlformats.org/officeDocument/2006/relationships">
+  <p:cSld>
+    <p:spTree>
+      <p:nvGrpSpPr>
+        <p:cNvPr id="1" name=""/>
+        <p:cNvGrpSpPr/>
+        <p:nvPr/>
+      </p:nvGrpSpPr>
+      <p:grpSpPr/>
+      <p:sp>
+        <p:nvSpPr>
+          <p:cNvPr id="2" name="TextBox 1"/>
+          <p:cNvSpPr txBox="1"/>
+          <p:nvPr/>
+        </p:nvSpPr>
+        <p:spPr>
+          <a:xfrm>
             <a:off x="548640" y="1280160"/>
             <a:ext cx="8229600" cy="3200400"/>
           </a:xfrm>
@@ -3381,6 +3971,50 @@
                 <a:latin typeface="Calibri"/>
               </a:rPr>
               <a:t>Extracted Requirements:</a:t>
+            </a:r>
+          </a:p>
+          <a:p>
+            <a:r>
+              <a:rPr sz="1400" b="0">
+                <a:solidFill>
+                  <a:srgbClr val="222222"/>
+                </a:solidFill>
+                <a:latin typeface="Calibri"/>
+              </a:rPr>
+              <a:t>• product_category</a:t>
+            </a:r>
+          </a:p>
+          <a:p>
+            <a:r>
+              <a:rPr sz="1400" b="0">
+                <a:solidFill>
+                  <a:srgbClr val="222222"/>
+                </a:solidFill>
+                <a:latin typeface="Calibri"/>
+              </a:rPr>
+              <a:t>• quantity</a:t>
+            </a:r>
+          </a:p>
+          <a:p>
+            <a:r>
+              <a:rPr sz="1400" b="0">
+                <a:solidFill>
+                  <a:srgbClr val="222222"/>
+                </a:solidFill>
+                <a:latin typeface="Calibri"/>
+              </a:rPr>
+              <a:t>• budget_per_unit</a:t>
+            </a:r>
+          </a:p>
+          <a:p>
+            <a:r>
+              <a:rPr sz="1400" b="0">
+                <a:solidFill>
+                  <a:srgbClr val="222222"/>
+                </a:solidFill>
+                <a:latin typeface="Calibri"/>
+              </a:rPr>
+              <a:t>• specific_requirements</a:t>
             </a:r>
           </a:p>
         </p:txBody>
@@ -4614,7 +5248,7 @@
                 <a:gridCol w="2468880"/>
                 <a:gridCol w="2468880"/>
               </a:tblGrid>
-              <a:tr h="718457">
+              <a:tr h="628650">
                 <a:tc>
                   <a:txBody>
                     <a:bodyPr/>
@@ -4652,7 +5286,7 @@
                   <a:tcPr/>
                 </a:tc>
               </a:tr>
-              <a:tr h="718457">
+              <a:tr h="628650">
                 <a:tc>
                   <a:txBody>
                     <a:bodyPr/>
@@ -4690,7 +5324,7 @@
                   <a:tcPr/>
                 </a:tc>
               </a:tr>
-              <a:tr h="718457">
+              <a:tr h="628650">
                 <a:tc>
                   <a:txBody>
                     <a:bodyPr/>
@@ -4703,6 +5337,44 @@
                           </a:solidFill>
                           <a:latin typeface="Calibri"/>
                         </a:rPr>
+                        <a:t>Cpu</a:t>
+                      </a:r>
+                    </a:p>
+                  </a:txBody>
+                  <a:tcPr/>
+                </a:tc>
+                <a:tc>
+                  <a:txBody>
+                    <a:bodyPr/>
+                    <a:lstStyle/>
+                    <a:p>
+                      <a:r>
+                        <a:rPr sz="1000" b="0">
+                          <a:solidFill>
+                            <a:srgbClr val="222222"/>
+                          </a:solidFill>
+                          <a:latin typeface="Calibri"/>
+                        </a:rPr>
+                        <a:t>Chipset integrated with processor</a:t>
+                      </a:r>
+                    </a:p>
+                  </a:txBody>
+                  <a:tcPr/>
+                </a:tc>
+              </a:tr>
+              <a:tr h="628650">
+                <a:tc>
+                  <a:txBody>
+                    <a:bodyPr/>
+                    <a:lstStyle/>
+                    <a:p>
+                      <a:r>
+                        <a:rPr sz="1000" b="0">
+                          <a:solidFill>
+                            <a:srgbClr val="222222"/>
+                          </a:solidFill>
+                          <a:latin typeface="Calibri"/>
+                        </a:rPr>
                         <a:t>Display</a:t>
                       </a:r>
                     </a:p>
@@ -4728,7 +5400,7 @@
                   <a:tcPr/>
                 </a:tc>
               </a:tr>
-              <a:tr h="718457">
+              <a:tr h="628650">
                 <a:tc>
                   <a:txBody>
                     <a:bodyPr/>
@@ -4766,7 +5438,7 @@
                   <a:tcPr/>
                 </a:tc>
               </a:tr>
-              <a:tr h="718457">
+              <a:tr h="628650">
                 <a:tc>
                   <a:txBody>
                     <a:bodyPr/>
@@ -4804,7 +5476,7 @@
                   <a:tcPr/>
                 </a:tc>
               </a:tr>
-              <a:tr h="718457">
+              <a:tr h="628650">
                 <a:tc>
                   <a:txBody>
                     <a:bodyPr/>
@@ -4842,7 +5514,7 @@
                   <a:tcPr/>
                 </a:tc>
               </a:tr>
-              <a:tr h="718458">
+              <a:tr h="628650">
                 <a:tc>
                   <a:txBody>
                     <a:bodyPr/>
@@ -5063,7 +5735,7 @@
                 <a:gridCol w="2468880"/>
                 <a:gridCol w="2468880"/>
               </a:tblGrid>
-              <a:tr h="718457">
+              <a:tr h="628650">
                 <a:tc>
                   <a:txBody>
                     <a:bodyPr/>
@@ -5101,7 +5773,7 @@
                   <a:tcPr/>
                 </a:tc>
               </a:tr>
-              <a:tr h="718457">
+              <a:tr h="628650">
                 <a:tc>
                   <a:txBody>
                     <a:bodyPr/>
@@ -5139,7 +5811,7 @@
                   <a:tcPr/>
                 </a:tc>
               </a:tr>
-              <a:tr h="718457">
+              <a:tr h="628650">
                 <a:tc>
                   <a:txBody>
                     <a:bodyPr/>
@@ -5152,6 +5824,44 @@
                           </a:solidFill>
                           <a:latin typeface="Calibri"/>
                         </a:rPr>
+                        <a:t>Cpu</a:t>
+                      </a:r>
+                    </a:p>
+                  </a:txBody>
+                  <a:tcPr/>
+                </a:tc>
+                <a:tc>
+                  <a:txBody>
+                    <a:bodyPr/>
+                    <a:lstStyle/>
+                    <a:p>
+                      <a:r>
+                        <a:rPr sz="1000" b="0">
+                          <a:solidFill>
+                            <a:srgbClr val="222222"/>
+                          </a:solidFill>
+                          <a:latin typeface="Calibri"/>
+                        </a:rPr>
+                        <a:t>Chipset integrated with processor</a:t>
+                      </a:r>
+                    </a:p>
+                  </a:txBody>
+                  <a:tcPr/>
+                </a:tc>
+              </a:tr>
+              <a:tr h="628650">
+                <a:tc>
+                  <a:txBody>
+                    <a:bodyPr/>
+                    <a:lstStyle/>
+                    <a:p>
+                      <a:r>
+                        <a:rPr sz="1000" b="0">
+                          <a:solidFill>
+                            <a:srgbClr val="222222"/>
+                          </a:solidFill>
+                          <a:latin typeface="Calibri"/>
+                        </a:rPr>
                         <a:t>Display</a:t>
                       </a:r>
                     </a:p>
@@ -5177,7 +5887,7 @@
                   <a:tcPr/>
                 </a:tc>
               </a:tr>
-              <a:tr h="718457">
+              <a:tr h="628650">
                 <a:tc>
                   <a:txBody>
                     <a:bodyPr/>
@@ -5215,7 +5925,7 @@
                   <a:tcPr/>
                 </a:tc>
               </a:tr>
-              <a:tr h="718457">
+              <a:tr h="628650">
                 <a:tc>
                   <a:txBody>
                     <a:bodyPr/>
@@ -5253,7 +5963,7 @@
                   <a:tcPr/>
                 </a:tc>
               </a:tr>
-              <a:tr h="718457">
+              <a:tr h="628650">
                 <a:tc>
                   <a:txBody>
                     <a:bodyPr/>
@@ -5291,7 +6001,7 @@
                   <a:tcPr/>
                 </a:tc>
               </a:tr>
-              <a:tr h="718458">
+              <a:tr h="628650">
                 <a:tc>
                   <a:txBody>
                     <a:bodyPr/>
@@ -5415,14 +6125,14 @@
                 </a:solidFill>
                 <a:latin typeface="Calibri"/>
               </a:rPr>
-              <a:t>HP ProBook 645 G1</a:t>
+              <a:t>HP ProBook 655 G1</a:t>
             </a:r>
           </a:p>
         </p:txBody>
       </p:sp>
       <p:pic>
         <p:nvPicPr>
-          <p:cNvPr id="3" name="Picture 2" descr="page_5_img_13.png"/>
+          <p:cNvPr id="3" name="Picture 2" descr="page_5_img_14.png"/>
           <p:cNvPicPr>
             <a:picLocks noChangeAspect="1"/>
           </p:cNvPicPr>
@@ -5485,7 +6195,7 @@
                 </a:solidFill>
                 <a:latin typeface="Calibri"/>
               </a:rPr>
-              <a:t>Challenge the Status Quo. Optimised for Windows 8 Pro. 2 this configurable laptop touts a 35.6 cm diagonal display, UMA graphics and AMD's latest technology. The professional design and HP 3D DriveGuard help protect your data from mobile use.</a:t>
+              <a:t>Challenge the Status Quo. Optimised for Windows 8 Pro. 2 this configurable laptop touts a 39.6 cm diagonal display, UMA graphics and AMD's latest technology. The professional design and HP 3D DriveGuard help protect your data from mobile use.</a:t>
             </a:r>
           </a:p>
         </p:txBody>
@@ -5512,7 +6222,7 @@
                 <a:gridCol w="2468880"/>
                 <a:gridCol w="2468880"/>
               </a:tblGrid>
-              <a:tr h="558800">
+              <a:tr h="502920">
                 <a:tc>
                   <a:txBody>
                     <a:bodyPr/>
@@ -5550,7 +6260,7 @@
                   <a:tcPr/>
                 </a:tc>
               </a:tr>
-              <a:tr h="558800">
+              <a:tr h="502920">
                 <a:tc>
                   <a:txBody>
                     <a:bodyPr/>
@@ -5588,7 +6298,7 @@
                   <a:tcPr/>
                 </a:tc>
               </a:tr>
-              <a:tr h="558800">
+              <a:tr h="502920">
                 <a:tc>
                   <a:txBody>
                     <a:bodyPr/>
@@ -5626,7 +6336,7 @@
                   <a:tcPr/>
                 </a:tc>
               </a:tr>
-              <a:tr h="558800">
+              <a:tr h="502920">
                 <a:tc>
                   <a:txBody>
                     <a:bodyPr/>
@@ -5664,7 +6374,7 @@
                   <a:tcPr/>
                 </a:tc>
               </a:tr>
-              <a:tr h="558800">
+              <a:tr h="502920">
                 <a:tc>
                   <a:txBody>
                     <a:bodyPr/>
@@ -5677,6 +6387,44 @@
                           </a:solidFill>
                           <a:latin typeface="Calibri"/>
                         </a:rPr>
+                        <a:t>Storage</a:t>
+                      </a:r>
+                    </a:p>
+                  </a:txBody>
+                  <a:tcPr/>
+                </a:tc>
+                <a:tc>
+                  <a:txBody>
+                    <a:bodyPr/>
+                    <a:lstStyle/>
+                    <a:p>
+                      <a:r>
+                        <a:rPr sz="1000" b="0">
+                          <a:solidFill>
+                            <a:srgbClr val="222222"/>
+                          </a:solidFill>
+                          <a:latin typeface="Calibri"/>
+                        </a:rPr>
+                        <a:t>HP 3D DriveGuard</a:t>
+                      </a:r>
+                    </a:p>
+                  </a:txBody>
+                  <a:tcPr/>
+                </a:tc>
+              </a:tr>
+              <a:tr h="502920">
+                <a:tc>
+                  <a:txBody>
+                    <a:bodyPr/>
+                    <a:lstStyle/>
+                    <a:p>
+                      <a:r>
+                        <a:rPr sz="1000" b="0">
+                          <a:solidFill>
+                            <a:srgbClr val="222222"/>
+                          </a:solidFill>
+                          <a:latin typeface="Calibri"/>
+                        </a:rPr>
                         <a:t>Display</a:t>
                       </a:r>
                     </a:p>
@@ -5695,14 +6443,14 @@
                           </a:solidFill>
                           <a:latin typeface="Calibri"/>
                         </a:rPr>
-                        <a:t>35.6 cm diagonal</a:t>
+                        <a:t>39.6 cm diagonal</a:t>
                       </a:r>
                     </a:p>
                   </a:txBody>
                   <a:tcPr/>
                 </a:tc>
               </a:tr>
-              <a:tr h="558800">
+              <a:tr h="502920">
                 <a:tc>
                   <a:txBody>
                     <a:bodyPr/>
@@ -5740,7 +6488,7 @@
                   <a:tcPr/>
                 </a:tc>
               </a:tr>
-              <a:tr h="558800">
+              <a:tr h="502920">
                 <a:tc>
                   <a:txBody>
                     <a:bodyPr/>
@@ -5771,14 +6519,14 @@
                           </a:solidFill>
                           <a:latin typeface="Calibri"/>
                         </a:rPr>
-                        <a:t>Starting at 2.0 kg</a:t>
+                        <a:t>Starting at 2.32 kg</a:t>
                       </a:r>
                     </a:p>
                   </a:txBody>
                   <a:tcPr/>
                 </a:tc>
               </a:tr>
-              <a:tr h="558800">
+              <a:tr h="502920">
                 <a:tc>
                   <a:txBody>
                     <a:bodyPr/>
@@ -5816,7 +6564,7 @@
                   <a:tcPr/>
                 </a:tc>
               </a:tr>
-              <a:tr h="558800">
+              <a:tr h="502920">
                 <a:tc>
                   <a:txBody>
                     <a:bodyPr/>
@@ -5888,7 +6636,7 @@
                 </a:solidFill>
                 <a:latin typeface="Calibri"/>
               </a:rPr>
-              <a:t>HP ProBook 645 G1 — Product Details</a:t>
+              <a:t>HP ProBook 655 G1 — Product Details</a:t>
             </a:r>
           </a:p>
         </p:txBody>
@@ -5971,7 +6719,7 @@
                 <a:gridCol w="1432560"/>
                 <a:gridCol w="1432560"/>
               </a:tblGrid>
-              <a:tr h="548640">
+              <a:tr h="493776">
                 <a:tc>
                   <a:txBody>
                     <a:bodyPr/>
@@ -6074,14 +6822,14 @@
                           </a:solidFill>
                           <a:latin typeface="Calibri"/>
                         </a:rPr>
-                        <a:t>HP ProBook 645 G1</a:t>
+                        <a:t>HP ProBook 655 G1</a:t>
                       </a:r>
                     </a:p>
                   </a:txBody>
                   <a:tcPr/>
                 </a:tc>
               </a:tr>
-              <a:tr h="548640">
+              <a:tr h="493776">
                 <a:tc>
                   <a:txBody>
                     <a:bodyPr/>
@@ -6191,7 +6939,7 @@
                   <a:tcPr/>
                 </a:tc>
               </a:tr>
-              <a:tr h="548640">
+              <a:tr h="493776">
                 <a:tc>
                   <a:txBody>
                     <a:bodyPr/>
@@ -6258,6 +7006,226 @@
                           </a:solidFill>
                           <a:latin typeface="Calibri"/>
                         </a:rPr>
+                        <a:t>Chipset integrated with processor</a:t>
+                      </a:r>
+                    </a:p>
+                  </a:txBody>
+                  <a:tcPr/>
+                </a:tc>
+                <a:tc>
+                  <a:txBody>
+                    <a:bodyPr/>
+                    <a:lstStyle/>
+                    <a:p>
+                      <a:r>
+                        <a:rPr sz="900" b="0">
+                          <a:solidFill>
+                            <a:srgbClr val="222222"/>
+                          </a:solidFill>
+                          <a:latin typeface="Calibri"/>
+                        </a:rPr>
+                        <a:t>Chipset integrated with processor</a:t>
+                      </a:r>
+                    </a:p>
+                  </a:txBody>
+                  <a:tcPr/>
+                </a:tc>
+                <a:tc>
+                  <a:txBody>
+                    <a:bodyPr/>
+                    <a:lstStyle/>
+                    <a:p>
+                      <a:r>
+                        <a:rPr sz="900" b="0">
+                          <a:solidFill>
+                            <a:srgbClr val="222222"/>
+                          </a:solidFill>
+                          <a:latin typeface="Calibri"/>
+                        </a:rPr>
+                        <a:t>AMD's latest technology</a:t>
+                      </a:r>
+                    </a:p>
+                  </a:txBody>
+                  <a:tcPr/>
+                </a:tc>
+              </a:tr>
+              <a:tr h="493776">
+                <a:tc>
+                  <a:txBody>
+                    <a:bodyPr/>
+                    <a:lstStyle/>
+                    <a:p>
+                      <a:r>
+                        <a:rPr sz="1000" b="1">
+                          <a:solidFill>
+                            <a:srgbClr val="222222"/>
+                          </a:solidFill>
+                          <a:latin typeface="Calibri"/>
+                        </a:rPr>
+                        <a:t>Display</a:t>
+                      </a:r>
+                    </a:p>
+                  </a:txBody>
+                  <a:tcPr/>
+                </a:tc>
+                <a:tc>
+                  <a:txBody>
+                    <a:bodyPr/>
+                    <a:lstStyle/>
+                    <a:p>
+                      <a:r>
+                        <a:rPr sz="900" b="0">
+                          <a:solidFill>
+                            <a:srgbClr val="222222"/>
+                          </a:solidFill>
+                          <a:latin typeface="Calibri"/>
+                        </a:rPr>
+                        <a:t>35.6 cm diagonal</a:t>
+                      </a:r>
+                    </a:p>
+                  </a:txBody>
+                  <a:tcPr/>
+                </a:tc>
+                <a:tc>
+                  <a:txBody>
+                    <a:bodyPr/>
+                    <a:lstStyle/>
+                    <a:p>
+                      <a:r>
+                        <a:rPr sz="900" b="0">
+                          <a:solidFill>
+                            <a:srgbClr val="222222"/>
+                          </a:solidFill>
+                          <a:latin typeface="Calibri"/>
+                        </a:rPr>
+                        <a:t>39.6 cm diagonal</a:t>
+                      </a:r>
+                    </a:p>
+                  </a:txBody>
+                  <a:tcPr/>
+                </a:tc>
+                <a:tc>
+                  <a:txBody>
+                    <a:bodyPr/>
+                    <a:lstStyle/>
+                    <a:p>
+                      <a:r>
+                        <a:rPr sz="900" b="0">
+                          <a:solidFill>
+                            <a:srgbClr val="222222"/>
+                          </a:solidFill>
+                          <a:latin typeface="Calibri"/>
+                        </a:rPr>
+                        <a:t>39.6 cm (15.6")</a:t>
+                      </a:r>
+                    </a:p>
+                  </a:txBody>
+                  <a:tcPr/>
+                </a:tc>
+                <a:tc>
+                  <a:txBody>
+                    <a:bodyPr/>
+                    <a:lstStyle/>
+                    <a:p>
+                      <a:r>
+                        <a:rPr sz="900" b="0">
+                          <a:solidFill>
+                            <a:srgbClr val="222222"/>
+                          </a:solidFill>
+                          <a:latin typeface="Calibri"/>
+                        </a:rPr>
+                        <a:t>35.6 cm (14")</a:t>
+                      </a:r>
+                    </a:p>
+                  </a:txBody>
+                  <a:tcPr/>
+                </a:tc>
+                <a:tc>
+                  <a:txBody>
+                    <a:bodyPr/>
+                    <a:lstStyle/>
+                    <a:p>
+                      <a:r>
+                        <a:rPr sz="900" b="0">
+                          <a:solidFill>
+                            <a:srgbClr val="222222"/>
+                          </a:solidFill>
+                          <a:latin typeface="Calibri"/>
+                        </a:rPr>
+                        <a:t>39.6 cm diagonal</a:t>
+                      </a:r>
+                    </a:p>
+                  </a:txBody>
+                  <a:tcPr/>
+                </a:tc>
+              </a:tr>
+              <a:tr h="493776">
+                <a:tc>
+                  <a:txBody>
+                    <a:bodyPr/>
+                    <a:lstStyle/>
+                    <a:p>
+                      <a:r>
+                        <a:rPr sz="1000" b="1">
+                          <a:solidFill>
+                            <a:srgbClr val="222222"/>
+                          </a:solidFill>
+                          <a:latin typeface="Calibri"/>
+                        </a:rPr>
+                        <a:t>Gpu</a:t>
+                      </a:r>
+                    </a:p>
+                  </a:txBody>
+                  <a:tcPr/>
+                </a:tc>
+                <a:tc>
+                  <a:txBody>
+                    <a:bodyPr/>
+                    <a:lstStyle/>
+                    <a:p>
+                      <a:r>
+                        <a:rPr sz="900" b="0">
+                          <a:solidFill>
+                            <a:srgbClr val="222222"/>
+                          </a:solidFill>
+                          <a:latin typeface="Calibri"/>
+                        </a:rPr>
+                        <a:t>UMA or discrete graphics</a:t>
+                      </a:r>
+                    </a:p>
+                  </a:txBody>
+                  <a:tcPr/>
+                </a:tc>
+                <a:tc>
+                  <a:txBody>
+                    <a:bodyPr/>
+                    <a:lstStyle/>
+                    <a:p>
+                      <a:r>
+                        <a:rPr sz="900" b="0">
+                          <a:solidFill>
+                            <a:srgbClr val="222222"/>
+                          </a:solidFill>
+                          <a:latin typeface="Calibri"/>
+                        </a:rPr>
+                        <a:t>UMA or discrete graphics</a:t>
+                      </a:r>
+                    </a:p>
+                  </a:txBody>
+                  <a:tcPr/>
+                </a:tc>
+                <a:tc>
+                  <a:txBody>
+                    <a:bodyPr/>
+                    <a:lstStyle/>
+                    <a:p>
+                      <a:r>
+                        <a:rPr sz="900" b="0">
+                          <a:solidFill>
+                            <a:srgbClr val="222222"/>
+                          </a:solidFill>
+                          <a:latin typeface="Calibri"/>
+                        </a:rPr>
                         <a:t>N/A</a:t>
                       </a:r>
                     </a:p>
@@ -6294,14 +7262,14 @@
                           </a:solidFill>
                           <a:latin typeface="Calibri"/>
                         </a:rPr>
-                        <a:t>AMD's latest technology</a:t>
+                        <a:t>UMA graphics</a:t>
                       </a:r>
                     </a:p>
                   </a:txBody>
                   <a:tcPr/>
                 </a:tc>
               </a:tr>
-              <a:tr h="548640">
+              <a:tr h="493776">
                 <a:tc>
                   <a:txBody>
                     <a:bodyPr/>
@@ -6314,7 +7282,7 @@
                           </a:solidFill>
                           <a:latin typeface="Calibri"/>
                         </a:rPr>
-                        <a:t>Display</a:t>
+                        <a:t>Os</a:t>
                       </a:r>
                     </a:p>
                   </a:txBody>
@@ -6332,7 +7300,7 @@
                           </a:solidFill>
                           <a:latin typeface="Calibri"/>
                         </a:rPr>
-                        <a:t>35.6 cm diagonal</a:t>
+                        <a:t>Windows 8 Pro</a:t>
                       </a:r>
                     </a:p>
                   </a:txBody>
@@ -6350,7 +7318,7 @@
                           </a:solidFill>
                           <a:latin typeface="Calibri"/>
                         </a:rPr>
-                        <a:t>39.6 cm diagonal</a:t>
+                        <a:t>Windows 8 Pro</a:t>
                       </a:r>
                     </a:p>
                   </a:txBody>
@@ -6368,7 +7336,7 @@
                           </a:solidFill>
                           <a:latin typeface="Calibri"/>
                         </a:rPr>
-                        <a:t>39.6 cm (15.6")</a:t>
+                        <a:t>Windows 8 Pro or other operating systems available</a:t>
                       </a:r>
                     </a:p>
                   </a:txBody>
@@ -6386,7 +7354,7 @@
                           </a:solidFill>
                           <a:latin typeface="Calibri"/>
                         </a:rPr>
-                        <a:t>35.6 cm (14")</a:t>
+                        <a:t>Windows 8 Pro or other operating systems available</a:t>
                       </a:r>
                     </a:p>
                   </a:txBody>
@@ -6404,14 +7372,14 @@
                           </a:solidFill>
                           <a:latin typeface="Calibri"/>
                         </a:rPr>
-                        <a:t>35.6 cm diagonal</a:t>
+                        <a:t>Windows 8 Pro</a:t>
                       </a:r>
                     </a:p>
                   </a:txBody>
                   <a:tcPr/>
                 </a:tc>
               </a:tr>
-              <a:tr h="548640">
+              <a:tr h="493776">
                 <a:tc>
                   <a:txBody>
                     <a:bodyPr/>
@@ -6424,7 +7392,7 @@
                           </a:solidFill>
                           <a:latin typeface="Calibri"/>
                         </a:rPr>
-                        <a:t>Gpu</a:t>
+                        <a:t>Ports</a:t>
                       </a:r>
                     </a:p>
                   </a:txBody>
@@ -6442,7 +7410,7 @@
                           </a:solidFill>
                           <a:latin typeface="Calibri"/>
                         </a:rPr>
-                        <a:t>UMA or discrete graphics</a:t>
+                        <a:t>1 ExpressCard/54; 1 Secure Digital; 2 USB 3.0; 2 USB 2.0; 1 stereo microphone in; 1 stereo headphone/line-out; 1 1394a; 1 AC power; 1 RJ-45; 1 docking connector; 1 secondary battery connector; 1 VGA; 1 serial; 1 RJ-11 (optional)</a:t>
                       </a:r>
                     </a:p>
                   </a:txBody>
@@ -6460,7 +7428,7 @@
                           </a:solidFill>
                           <a:latin typeface="Calibri"/>
                         </a:rPr>
-                        <a:t>UMA or discrete graphics</a:t>
+                        <a:t>1 ExpressCard/54; 1 Secure Digital; 2 USB 3.0; 2 USB 2.0; 1 stereo microphone in; 1 stereo headphone/line-out; 1 1394a; 1 AC power; 1 RJ-45; 1 docking connector; 1 secondary battery connector; 1 VGA; 1 serial; 1 RJ-11 (optional)</a:t>
                       </a:r>
                     </a:p>
                   </a:txBody>
@@ -6478,6 +7446,190 @@
                           </a:solidFill>
                           <a:latin typeface="Calibri"/>
                         </a:rPr>
+                        <a:t>1 Media Card Reader; 3 USB 3.0; 1 USB 3.0 charging; 1 DisplayPort 1.2; 1 VGA; 1 combo stereo headphone/mic jack; 1 AC power; 1 RJ-45; 1 docking connector; 1 secondary battery connector</a:t>
+                      </a:r>
+                    </a:p>
+                  </a:txBody>
+                  <a:tcPr/>
+                </a:tc>
+                <a:tc>
+                  <a:txBody>
+                    <a:bodyPr/>
+                    <a:lstStyle/>
+                    <a:p>
+                      <a:r>
+                        <a:rPr sz="900" b="0">
+                          <a:solidFill>
+                            <a:srgbClr val="222222"/>
+                          </a:solidFill>
+                          <a:latin typeface="Calibri"/>
+                        </a:rPr>
+                        <a:t>1 Media Card Reader; 3 USB 3.0; 1 USB 3.0 charging; 1 DisplayPort 1.2; 1 VGA; 1 combo stereo headphone/mic jack; 1 AC power; 1 RJ-45; 1 side docking connector</a:t>
+                      </a:r>
+                    </a:p>
+                  </a:txBody>
+                  <a:tcPr/>
+                </a:tc>
+                <a:tc>
+                  <a:txBody>
+                    <a:bodyPr/>
+                    <a:lstStyle/>
+                    <a:p>
+                      <a:r>
+                        <a:rPr sz="900" b="0">
+                          <a:solidFill>
+                            <a:srgbClr val="222222"/>
+                          </a:solidFill>
+                          <a:latin typeface="Calibri"/>
+                        </a:rPr>
+                        <a:t>1 ExpressCard/54; 1 Secure Digital; 2 USB 3.0; 2 USB 2.0; 1 stereo microphone in; 1 stereo headphone/line-out; 1 1394a; 1 AC power; 1 RJ-45; 1 docking connector; 1 secondary battery connector; 1 VGA; 1 serial; 1 RJ-11 (optional)</a:t>
+                      </a:r>
+                    </a:p>
+                  </a:txBody>
+                  <a:tcPr/>
+                </a:tc>
+              </a:tr>
+              <a:tr h="493776">
+                <a:tc>
+                  <a:txBody>
+                    <a:bodyPr/>
+                    <a:lstStyle/>
+                    <a:p>
+                      <a:r>
+                        <a:rPr sz="1000" b="1">
+                          <a:solidFill>
+                            <a:srgbClr val="222222"/>
+                          </a:solidFill>
+                          <a:latin typeface="Calibri"/>
+                        </a:rPr>
+                        <a:t>Ram</a:t>
+                      </a:r>
+                    </a:p>
+                  </a:txBody>
+                  <a:tcPr/>
+                </a:tc>
+                <a:tc>
+                  <a:txBody>
+                    <a:bodyPr/>
+                    <a:lstStyle/>
+                    <a:p>
+                      <a:r>
+                        <a:rPr sz="900" b="0">
+                          <a:solidFill>
+                            <a:srgbClr val="222222"/>
+                          </a:solidFill>
+                          <a:latin typeface="Calibri"/>
+                        </a:rPr>
+                        <a:t>Upgradeable to 16 GB</a:t>
+                      </a:r>
+                    </a:p>
+                  </a:txBody>
+                  <a:tcPr/>
+                </a:tc>
+                <a:tc>
+                  <a:txBody>
+                    <a:bodyPr/>
+                    <a:lstStyle/>
+                    <a:p>
+                      <a:r>
+                        <a:rPr sz="900" b="0">
+                          <a:solidFill>
+                            <a:srgbClr val="222222"/>
+                          </a:solidFill>
+                          <a:latin typeface="Calibri"/>
+                        </a:rPr>
+                        <a:t>Upgradeable to 16 GB</a:t>
+                      </a:r>
+                    </a:p>
+                  </a:txBody>
+                  <a:tcPr/>
+                </a:tc>
+                <a:tc>
+                  <a:txBody>
+                    <a:bodyPr/>
+                    <a:lstStyle/>
+                    <a:p>
+                      <a:r>
+                        <a:rPr sz="900" b="0">
+                          <a:solidFill>
+                            <a:srgbClr val="222222"/>
+                          </a:solidFill>
+                          <a:latin typeface="Calibri"/>
+                        </a:rPr>
+                        <a:t>Upgradeable to 16 GB</a:t>
+                      </a:r>
+                    </a:p>
+                  </a:txBody>
+                  <a:tcPr/>
+                </a:tc>
+                <a:tc>
+                  <a:txBody>
+                    <a:bodyPr/>
+                    <a:lstStyle/>
+                    <a:p>
+                      <a:r>
+                        <a:rPr sz="900" b="0">
+                          <a:solidFill>
+                            <a:srgbClr val="222222"/>
+                          </a:solidFill>
+                          <a:latin typeface="Calibri"/>
+                        </a:rPr>
+                        <a:t>Upgradeable to 16 GB</a:t>
+                      </a:r>
+                    </a:p>
+                  </a:txBody>
+                  <a:tcPr/>
+                </a:tc>
+                <a:tc>
+                  <a:txBody>
+                    <a:bodyPr/>
+                    <a:lstStyle/>
+                    <a:p>
+                      <a:r>
+                        <a:rPr sz="900" b="0">
+                          <a:solidFill>
+                            <a:srgbClr val="222222"/>
+                          </a:solidFill>
+                          <a:latin typeface="Calibri"/>
+                        </a:rPr>
+                        <a:t>Upgradeable to 16 GB</a:t>
+                      </a:r>
+                    </a:p>
+                  </a:txBody>
+                  <a:tcPr/>
+                </a:tc>
+              </a:tr>
+              <a:tr h="493776">
+                <a:tc>
+                  <a:txBody>
+                    <a:bodyPr/>
+                    <a:lstStyle/>
+                    <a:p>
+                      <a:r>
+                        <a:rPr sz="1000" b="1">
+                          <a:solidFill>
+                            <a:srgbClr val="222222"/>
+                          </a:solidFill>
+                          <a:latin typeface="Calibri"/>
+                        </a:rPr>
+                        <a:t>Storage</a:t>
+                      </a:r>
+                    </a:p>
+                  </a:txBody>
+                  <a:tcPr/>
+                </a:tc>
+                <a:tc>
+                  <a:txBody>
+                    <a:bodyPr/>
+                    <a:lstStyle/>
+                    <a:p>
+                      <a:r>
+                        <a:rPr sz="900" b="0">
+                          <a:solidFill>
+                            <a:srgbClr val="222222"/>
+                          </a:solidFill>
+                          <a:latin typeface="Calibri"/>
+                        </a:rPr>
                         <a:t>N/A</a:t>
                       </a:r>
                     </a:p>
@@ -6514,14 +7666,50 @@
                           </a:solidFill>
                           <a:latin typeface="Calibri"/>
                         </a:rPr>
-                        <a:t>UMA graphics</a:t>
+                        <a:t>N/A</a:t>
+                      </a:r>
+                    </a:p>
+                  </a:txBody>
+                  <a:tcPr/>
+                </a:tc>
+                <a:tc>
+                  <a:txBody>
+                    <a:bodyPr/>
+                    <a:lstStyle/>
+                    <a:p>
+                      <a:r>
+                        <a:rPr sz="900" b="0">
+                          <a:solidFill>
+                            <a:srgbClr val="222222"/>
+                          </a:solidFill>
+                          <a:latin typeface="Calibri"/>
+                        </a:rPr>
+                        <a:t>N/A</a:t>
+                      </a:r>
+                    </a:p>
+                  </a:txBody>
+                  <a:tcPr/>
+                </a:tc>
+                <a:tc>
+                  <a:txBody>
+                    <a:bodyPr/>
+                    <a:lstStyle/>
+                    <a:p>
+                      <a:r>
+                        <a:rPr sz="900" b="0">
+                          <a:solidFill>
+                            <a:srgbClr val="222222"/>
+                          </a:solidFill>
+                          <a:latin typeface="Calibri"/>
+                        </a:rPr>
+                        <a:t>HP 3D DriveGuard</a:t>
                       </a:r>
                     </a:p>
                   </a:txBody>
                   <a:tcPr/>
                 </a:tc>
               </a:tr>
-              <a:tr h="548640">
+              <a:tr h="493776">
                 <a:tc>
                   <a:txBody>
                     <a:bodyPr/>
@@ -6534,7 +7722,7 @@
                           </a:solidFill>
                           <a:latin typeface="Calibri"/>
                         </a:rPr>
-                        <a:t>Os</a:t>
+                        <a:t>Weight</a:t>
                       </a:r>
                     </a:p>
                   </a:txBody>
@@ -6552,7 +7740,7 @@
                           </a:solidFill>
                           <a:latin typeface="Calibri"/>
                         </a:rPr>
-                        <a:t>Windows 8 Pro</a:t>
+                        <a:t>Starting at 2.0 kg</a:t>
                       </a:r>
                     </a:p>
                   </a:txBody>
@@ -6570,7 +7758,7 @@
                           </a:solidFill>
                           <a:latin typeface="Calibri"/>
                         </a:rPr>
-                        <a:t>Windows 8 Pro</a:t>
+                        <a:t>Starting at 2.32 kg</a:t>
                       </a:r>
                     </a:p>
                   </a:txBody>
@@ -6588,7 +7776,7 @@
                           </a:solidFill>
                           <a:latin typeface="Calibri"/>
                         </a:rPr>
-                        <a:t>Windows 8 Pro or other operating systems available</a:t>
+                        <a:t>Starting at 1.88 kg</a:t>
                       </a:r>
                     </a:p>
                   </a:txBody>
@@ -6606,7 +7794,7 @@
                           </a:solidFill>
                           <a:latin typeface="Calibri"/>
                         </a:rPr>
-                        <a:t>Windows 8 Pro or other operating systems available</a:t>
+                        <a:t>Starting at 1.58 kg</a:t>
                       </a:r>
                     </a:p>
                   </a:txBody>
@@ -6624,337 +7812,7 @@
                           </a:solidFill>
                           <a:latin typeface="Calibri"/>
                         </a:rPr>
-                        <a:t>Windows 8 Pro</a:t>
-                      </a:r>
-                    </a:p>
-                  </a:txBody>
-                  <a:tcPr/>
-                </a:tc>
-              </a:tr>
-              <a:tr h="548640">
-                <a:tc>
-                  <a:txBody>
-                    <a:bodyPr/>
-                    <a:lstStyle/>
-                    <a:p>
-                      <a:r>
-                        <a:rPr sz="1000" b="1">
-                          <a:solidFill>
-                            <a:srgbClr val="222222"/>
-                          </a:solidFill>
-                          <a:latin typeface="Calibri"/>
-                        </a:rPr>
-                        <a:t>Ports</a:t>
-                      </a:r>
-                    </a:p>
-                  </a:txBody>
-                  <a:tcPr/>
-                </a:tc>
-                <a:tc>
-                  <a:txBody>
-                    <a:bodyPr/>
-                    <a:lstStyle/>
-                    <a:p>
-                      <a:r>
-                        <a:rPr sz="900" b="0">
-                          <a:solidFill>
-                            <a:srgbClr val="222222"/>
-                          </a:solidFill>
-                          <a:latin typeface="Calibri"/>
-                        </a:rPr>
-                        <a:t>1 ExpressCard/54; 1 Secure Digital; 2 USB 3.0; 2 USB 2.0; 1 stereo microphone in; 1 stereo headphone/line-out; 1 1394a; 1 AC power; 1 RJ-45; 1 docking connector; 1 secondary battery connector; 1 VGA; 1 serial; 1 RJ-11 (optional)</a:t>
-                      </a:r>
-                    </a:p>
-                  </a:txBody>
-                  <a:tcPr/>
-                </a:tc>
-                <a:tc>
-                  <a:txBody>
-                    <a:bodyPr/>
-                    <a:lstStyle/>
-                    <a:p>
-                      <a:r>
-                        <a:rPr sz="900" b="0">
-                          <a:solidFill>
-                            <a:srgbClr val="222222"/>
-                          </a:solidFill>
-                          <a:latin typeface="Calibri"/>
-                        </a:rPr>
-                        <a:t>1 ExpressCard/54; 1 Secure Digital; 2 USB 3.0; 2 USB 2.0; 1 stereo microphone in; 1 stereo headphone/line-out; 1 1394a; 1 AC power; 1 RJ-45; 1 docking connector; 1 secondary battery connector; 1 VGA; 1 serial; 1 RJ-11 (optional)</a:t>
-                      </a:r>
-                    </a:p>
-                  </a:txBody>
-                  <a:tcPr/>
-                </a:tc>
-                <a:tc>
-                  <a:txBody>
-                    <a:bodyPr/>
-                    <a:lstStyle/>
-                    <a:p>
-                      <a:r>
-                        <a:rPr sz="900" b="0">
-                          <a:solidFill>
-                            <a:srgbClr val="222222"/>
-                          </a:solidFill>
-                          <a:latin typeface="Calibri"/>
-                        </a:rPr>
-                        <a:t>1 Media Card Reader; 3 USB 3.0; 1 USB 3.0 charging; 1 DisplayPort 1.2; 1 VGA; 1 combo stereo headphone/mic jack; 1 AC power; 1 RJ-45; 1 docking connector; 1 secondary battery connector</a:t>
-                      </a:r>
-                    </a:p>
-                  </a:txBody>
-                  <a:tcPr/>
-                </a:tc>
-                <a:tc>
-                  <a:txBody>
-                    <a:bodyPr/>
-                    <a:lstStyle/>
-                    <a:p>
-                      <a:r>
-                        <a:rPr sz="900" b="0">
-                          <a:solidFill>
-                            <a:srgbClr val="222222"/>
-                          </a:solidFill>
-                          <a:latin typeface="Calibri"/>
-                        </a:rPr>
-                        <a:t>1 Media Card Reader; 3 USB 3.0; 1 USB 3.0 charging; 1 DisplayPort 1.2; 1 VGA; 1 combo stereo headphone/mic jack; 1 AC power; 1 RJ-45; 1 side docking connector</a:t>
-                      </a:r>
-                    </a:p>
-                  </a:txBody>
-                  <a:tcPr/>
-                </a:tc>
-                <a:tc>
-                  <a:txBody>
-                    <a:bodyPr/>
-                    <a:lstStyle/>
-                    <a:p>
-                      <a:r>
-                        <a:rPr sz="900" b="0">
-                          <a:solidFill>
-                            <a:srgbClr val="222222"/>
-                          </a:solidFill>
-                          <a:latin typeface="Calibri"/>
-                        </a:rPr>
-                        <a:t>1 ExpressCard/54; 1 Secure Digital; 2 USB 3.0; 2 USB 2.0; 1 stereo microphone in; 1 stereo headphone/line-out; 1 1394a; 1 AC power; 1 RJ-45; 1 docking connector; 1 secondary battery connector; 1 VGA; 1 serial; 1 RJ-11 (optional)</a:t>
-                      </a:r>
-                    </a:p>
-                  </a:txBody>
-                  <a:tcPr/>
-                </a:tc>
-              </a:tr>
-              <a:tr h="548640">
-                <a:tc>
-                  <a:txBody>
-                    <a:bodyPr/>
-                    <a:lstStyle/>
-                    <a:p>
-                      <a:r>
-                        <a:rPr sz="1000" b="1">
-                          <a:solidFill>
-                            <a:srgbClr val="222222"/>
-                          </a:solidFill>
-                          <a:latin typeface="Calibri"/>
-                        </a:rPr>
-                        <a:t>Ram</a:t>
-                      </a:r>
-                    </a:p>
-                  </a:txBody>
-                  <a:tcPr/>
-                </a:tc>
-                <a:tc>
-                  <a:txBody>
-                    <a:bodyPr/>
-                    <a:lstStyle/>
-                    <a:p>
-                      <a:r>
-                        <a:rPr sz="900" b="0">
-                          <a:solidFill>
-                            <a:srgbClr val="222222"/>
-                          </a:solidFill>
-                          <a:latin typeface="Calibri"/>
-                        </a:rPr>
-                        <a:t>Upgradeable to 16 GB</a:t>
-                      </a:r>
-                    </a:p>
-                  </a:txBody>
-                  <a:tcPr/>
-                </a:tc>
-                <a:tc>
-                  <a:txBody>
-                    <a:bodyPr/>
-                    <a:lstStyle/>
-                    <a:p>
-                      <a:r>
-                        <a:rPr sz="900" b="0">
-                          <a:solidFill>
-                            <a:srgbClr val="222222"/>
-                          </a:solidFill>
-                          <a:latin typeface="Calibri"/>
-                        </a:rPr>
-                        <a:t>Upgradeable to 16 GB</a:t>
-                      </a:r>
-                    </a:p>
-                  </a:txBody>
-                  <a:tcPr/>
-                </a:tc>
-                <a:tc>
-                  <a:txBody>
-                    <a:bodyPr/>
-                    <a:lstStyle/>
-                    <a:p>
-                      <a:r>
-                        <a:rPr sz="900" b="0">
-                          <a:solidFill>
-                            <a:srgbClr val="222222"/>
-                          </a:solidFill>
-                          <a:latin typeface="Calibri"/>
-                        </a:rPr>
-                        <a:t>Upgradeable to 16 GB</a:t>
-                      </a:r>
-                    </a:p>
-                  </a:txBody>
-                  <a:tcPr/>
-                </a:tc>
-                <a:tc>
-                  <a:txBody>
-                    <a:bodyPr/>
-                    <a:lstStyle/>
-                    <a:p>
-                      <a:r>
-                        <a:rPr sz="900" b="0">
-                          <a:solidFill>
-                            <a:srgbClr val="222222"/>
-                          </a:solidFill>
-                          <a:latin typeface="Calibri"/>
-                        </a:rPr>
-                        <a:t>Upgradeable to 16 GB</a:t>
-                      </a:r>
-                    </a:p>
-                  </a:txBody>
-                  <a:tcPr/>
-                </a:tc>
-                <a:tc>
-                  <a:txBody>
-                    <a:bodyPr/>
-                    <a:lstStyle/>
-                    <a:p>
-                      <a:r>
-                        <a:rPr sz="900" b="0">
-                          <a:solidFill>
-                            <a:srgbClr val="222222"/>
-                          </a:solidFill>
-                          <a:latin typeface="Calibri"/>
-                        </a:rPr>
-                        <a:t>Upgradeable to 16 GB</a:t>
-                      </a:r>
-                    </a:p>
-                  </a:txBody>
-                  <a:tcPr/>
-                </a:tc>
-              </a:tr>
-              <a:tr h="548640">
-                <a:tc>
-                  <a:txBody>
-                    <a:bodyPr/>
-                    <a:lstStyle/>
-                    <a:p>
-                      <a:r>
-                        <a:rPr sz="1000" b="1">
-                          <a:solidFill>
-                            <a:srgbClr val="222222"/>
-                          </a:solidFill>
-                          <a:latin typeface="Calibri"/>
-                        </a:rPr>
-                        <a:t>Weight</a:t>
-                      </a:r>
-                    </a:p>
-                  </a:txBody>
-                  <a:tcPr/>
-                </a:tc>
-                <a:tc>
-                  <a:txBody>
-                    <a:bodyPr/>
-                    <a:lstStyle/>
-                    <a:p>
-                      <a:r>
-                        <a:rPr sz="900" b="0">
-                          <a:solidFill>
-                            <a:srgbClr val="222222"/>
-                          </a:solidFill>
-                          <a:latin typeface="Calibri"/>
-                        </a:rPr>
-                        <a:t>Starting at 2.0 kg</a:t>
-                      </a:r>
-                    </a:p>
-                  </a:txBody>
-                  <a:tcPr/>
-                </a:tc>
-                <a:tc>
-                  <a:txBody>
-                    <a:bodyPr/>
-                    <a:lstStyle/>
-                    <a:p>
-                      <a:r>
-                        <a:rPr sz="900" b="0">
-                          <a:solidFill>
-                            <a:srgbClr val="222222"/>
-                          </a:solidFill>
-                          <a:latin typeface="Calibri"/>
-                        </a:rPr>
                         <a:t>Starting at 2.32 kg</a:t>
-                      </a:r>
-                    </a:p>
-                  </a:txBody>
-                  <a:tcPr/>
-                </a:tc>
-                <a:tc>
-                  <a:txBody>
-                    <a:bodyPr/>
-                    <a:lstStyle/>
-                    <a:p>
-                      <a:r>
-                        <a:rPr sz="900" b="0">
-                          <a:solidFill>
-                            <a:srgbClr val="222222"/>
-                          </a:solidFill>
-                          <a:latin typeface="Calibri"/>
-                        </a:rPr>
-                        <a:t>Starting at 1.88 kg</a:t>
-                      </a:r>
-                    </a:p>
-                  </a:txBody>
-                  <a:tcPr/>
-                </a:tc>
-                <a:tc>
-                  <a:txBody>
-                    <a:bodyPr/>
-                    <a:lstStyle/>
-                    <a:p>
-                      <a:r>
-                        <a:rPr sz="900" b="0">
-                          <a:solidFill>
-                            <a:srgbClr val="222222"/>
-                          </a:solidFill>
-                          <a:latin typeface="Calibri"/>
-                        </a:rPr>
-                        <a:t>Starting at 1.58 kg</a:t>
-                      </a:r>
-                    </a:p>
-                  </a:txBody>
-                  <a:tcPr/>
-                </a:tc>
-                <a:tc>
-                  <a:txBody>
-                    <a:bodyPr/>
-                    <a:lstStyle/>
-                    <a:p>
-                      <a:r>
-                        <a:rPr sz="900" b="0">
-                          <a:solidFill>
-                            <a:srgbClr val="222222"/>
-                          </a:solidFill>
-                          <a:latin typeface="Calibri"/>
-                        </a:rPr>
-                        <a:t>Starting at 2.0 kg</a:t>
                       </a:r>
                     </a:p>
                   </a:txBody>
@@ -7026,8 +7884,8 @@
         </p:nvSpPr>
         <p:spPr>
           <a:xfrm>
-            <a:off x="548640" y="457200"/>
-            <a:ext cx="8229600" cy="640080"/>
+            <a:off x="457200" y="182880"/>
+            <a:ext cx="8229600" cy="548640"/>
           </a:xfrm>
           <a:prstGeom prst="rect">
             <a:avLst/>
@@ -7040,14 +7898,11 @@
           </a:bodyPr>
           <a:lstStyle/>
           <a:p>
-            <a:r>
-              <a:rPr sz="2200" b="1">
-                <a:solidFill>
-                  <a:srgbClr val="004279"/>
-                </a:solidFill>
-                <a:latin typeface="Calibri"/>
-              </a:rPr>
-              <a:t>Upsell Options</a:t>
+            <a:pPr>
+              <a:defRPr sz="2800" b="1"/>
+            </a:pPr>
+            <a:r>
+              <a:t>Upsell Recommendations — Page 1</a:t>
             </a:r>
           </a:p>
         </p:txBody>
@@ -7060,8 +7915,8 @@
         </p:nvSpPr>
         <p:spPr>
           <a:xfrm>
-            <a:off x="548640" y="1188720"/>
-            <a:ext cx="7772400" cy="4937760"/>
+            <a:off x="457200" y="1097280"/>
+            <a:ext cx="2743200" cy="365760"/>
           </a:xfrm>
           <a:prstGeom prst="rect">
             <a:avLst/>
@@ -7069,89 +7924,58 @@
           <a:noFill/>
         </p:spPr>
         <p:txBody>
-          <a:bodyPr wrap="none">
+          <a:bodyPr wrap="square">
             <a:spAutoFit/>
           </a:bodyPr>
           <a:lstStyle/>
-          <a:p/>
-          <a:p>
-            <a:r>
-              <a:rPr sz="1400" b="0">
+          <a:p>
+            <a:pPr algn="ctr">
+              <a:defRPr sz="2200" b="1">
                 <a:solidFill>
-                  <a:srgbClr val="222222"/>
+                  <a:srgbClr val="000000"/>
                 </a:solidFill>
-                <a:latin typeface="Calibri"/>
-              </a:rPr>
-              <a:t>• G — N/A</a:t>
-            </a:r>
-          </a:p>
-          <a:p>
-            <a:r>
-              <a:rPr sz="1400" b="0">
-                <a:solidFill>
-                  <a:srgbClr val="222222"/>
-                </a:solidFill>
-                <a:latin typeface="Calibri"/>
-              </a:rPr>
-              <a:t>• i — N/A</a:t>
-            </a:r>
-          </a:p>
-          <a:p>
-            <a:r>
-              <a:rPr sz="1400" b="0">
-                <a:solidFill>
-                  <a:srgbClr val="222222"/>
-                </a:solidFill>
-                <a:latin typeface="Calibri"/>
-              </a:rPr>
-              <a:t>• v — N/A</a:t>
-            </a:r>
-          </a:p>
-          <a:p>
-            <a:r>
-              <a:rPr sz="1400" b="0">
-                <a:solidFill>
-                  <a:srgbClr val="222222"/>
-                </a:solidFill>
-                <a:latin typeface="Calibri"/>
-              </a:rPr>
-              <a:t>• e — N/A</a:t>
-            </a:r>
-          </a:p>
-          <a:p>
-            <a:r>
-              <a:rPr sz="1400" b="0">
-                <a:solidFill>
-                  <a:srgbClr val="222222"/>
-                </a:solidFill>
-                <a:latin typeface="Calibri"/>
-              </a:rPr>
-              <a:t>• n — N/A</a:t>
-            </a:r>
-          </a:p>
-          <a:p>
-            <a:r>
-              <a:rPr sz="1400" b="0">
-                <a:solidFill>
-                  <a:srgbClr val="222222"/>
-                </a:solidFill>
-                <a:latin typeface="Calibri"/>
-              </a:rPr>
-              <a:t>•   — N/A</a:t>
-            </a:r>
-          </a:p>
-        </p:txBody>
-      </p:sp>
-      <p:sp>
-        <p:nvSpPr>
-          <p:cNvPr id="4" name="TextBox 3"/>
+              </a:defRPr>
+            </a:pPr>
+            <a:r>
+              <a:t>Mouse</a:t>
+            </a:r>
+          </a:p>
+        </p:txBody>
+      </p:sp>
+      <p:pic>
+        <p:nvPicPr>
+          <p:cNvPr id="4" name="Picture 3" descr="page_4_img_4.png"/>
+          <p:cNvPicPr>
+            <a:picLocks noChangeAspect="1"/>
+          </p:cNvPicPr>
+          <p:nvPr/>
+        </p:nvPicPr>
+        <p:blipFill>
+          <a:blip r:embed="rId2"/>
+          <a:stretch>
+            <a:fillRect/>
+          </a:stretch>
+        </p:blipFill>
+        <p:spPr>
+          <a:xfrm>
+            <a:off x="1504950" y="1463040"/>
+            <a:ext cx="647700" cy="914400"/>
+          </a:xfrm>
+          <a:prstGeom prst="rect">
+            <a:avLst/>
+          </a:prstGeom>
+        </p:spPr>
+      </p:pic>
+      <p:sp>
+        <p:nvSpPr>
+          <p:cNvPr id="5" name="TextBox 4"/>
           <p:cNvSpPr txBox="1"/>
           <p:nvPr/>
         </p:nvSpPr>
         <p:spPr>
           <a:xfrm>
-            <a:off x="548640" y="6400800"/>
-            <a:ext cx="8229600" cy="365760"/>
+            <a:off x="457200" y="2377440"/>
+            <a:ext cx="2743200" cy="329184"/>
           </a:xfrm>
           <a:prstGeom prst="rect">
             <a:avLst/>
@@ -7159,20 +7983,592 @@
           <a:noFill/>
         </p:spPr>
         <p:txBody>
-          <a:bodyPr wrap="none">
+          <a:bodyPr wrap="square">
             <a:spAutoFit/>
           </a:bodyPr>
           <a:lstStyle/>
           <a:p>
-            <a:pPr algn="l"/>
-            <a:r>
-              <a:rPr sz="900" b="0">
+            <a:pPr algn="ctr">
+              <a:defRPr sz="1400" b="1">
                 <a:solidFill>
-                  <a:srgbClr val="787878"/>
+                  <a:srgbClr val="000000"/>
                 </a:solidFill>
-                <a:latin typeface="Calibri"/>
-              </a:rPr>
-              <a:t>Upsell Suggestions</a:t>
+              </a:defRPr>
+            </a:pPr>
+            <a:r>
+              <a:t>HP X4000b Bluetooth Mouse</a:t>
+            </a:r>
+          </a:p>
+        </p:txBody>
+      </p:sp>
+      <p:sp>
+        <p:nvSpPr>
+          <p:cNvPr id="6" name="TextBox 5"/>
+          <p:cNvSpPr txBox="1"/>
+          <p:nvPr/>
+        </p:nvSpPr>
+        <p:spPr>
+          <a:xfrm>
+            <a:off x="457200" y="2706624"/>
+            <a:ext cx="2743200" cy="585216"/>
+          </a:xfrm>
+          <a:prstGeom prst="rect">
+            <a:avLst/>
+          </a:prstGeom>
+          <a:noFill/>
+        </p:spPr>
+        <p:txBody>
+          <a:bodyPr wrap="square">
+            <a:spAutoFit/>
+          </a:bodyPr>
+          <a:lstStyle/>
+          <a:p>
+            <a:pPr algn="l">
+              <a:defRPr sz="1100" b="0">
+                <a:solidFill>
+                  <a:srgbClr val="000000"/>
+                </a:solidFill>
+              </a:defRPr>
+            </a:pPr>
+            <a:r>
+              <a:t>Be more productive on the go with the sleek, stylish HP X4000b Bluetoo</a:t>
+            </a:r>
+          </a:p>
+        </p:txBody>
+      </p:sp>
+      <p:pic>
+        <p:nvPicPr>
+          <p:cNvPr id="7" name="Picture 6" descr="page_4_img_5.png"/>
+          <p:cNvPicPr>
+            <a:picLocks noChangeAspect="1"/>
+          </p:cNvPicPr>
+          <p:nvPr/>
+        </p:nvPicPr>
+        <p:blipFill>
+          <a:blip r:embed="rId3"/>
+          <a:stretch>
+            <a:fillRect/>
+          </a:stretch>
+        </p:blipFill>
+        <p:spPr>
+          <a:xfrm>
+            <a:off x="1521823" y="3291840"/>
+            <a:ext cx="613954" cy="914400"/>
+          </a:xfrm>
+          <a:prstGeom prst="rect">
+            <a:avLst/>
+          </a:prstGeom>
+        </p:spPr>
+      </p:pic>
+      <p:sp>
+        <p:nvSpPr>
+          <p:cNvPr id="8" name="TextBox 7"/>
+          <p:cNvSpPr txBox="1"/>
+          <p:nvPr/>
+        </p:nvSpPr>
+        <p:spPr>
+          <a:xfrm>
+            <a:off x="457200" y="4206240"/>
+            <a:ext cx="2743200" cy="329184"/>
+          </a:xfrm>
+          <a:prstGeom prst="rect">
+            <a:avLst/>
+          </a:prstGeom>
+          <a:noFill/>
+        </p:spPr>
+        <p:txBody>
+          <a:bodyPr wrap="square">
+            <a:spAutoFit/>
+          </a:bodyPr>
+          <a:lstStyle/>
+          <a:p>
+            <a:pPr algn="ctr">
+              <a:defRPr sz="1400" b="1">
+                <a:solidFill>
+                  <a:srgbClr val="000000"/>
+                </a:solidFill>
+              </a:defRPr>
+            </a:pPr>
+            <a:r>
+              <a:t>HP Bluetooth TTP Mouse</a:t>
+            </a:r>
+          </a:p>
+        </p:txBody>
+      </p:sp>
+      <p:sp>
+        <p:nvSpPr>
+          <p:cNvPr id="9" name="TextBox 8"/>
+          <p:cNvSpPr txBox="1"/>
+          <p:nvPr/>
+        </p:nvSpPr>
+        <p:spPr>
+          <a:xfrm>
+            <a:off x="457200" y="4535424"/>
+            <a:ext cx="2743200" cy="585216"/>
+          </a:xfrm>
+          <a:prstGeom prst="rect">
+            <a:avLst/>
+          </a:prstGeom>
+          <a:noFill/>
+        </p:spPr>
+        <p:txBody>
+          <a:bodyPr wrap="square">
+            <a:spAutoFit/>
+          </a:bodyPr>
+          <a:lstStyle/>
+          <a:p>
+            <a:pPr algn="l">
+              <a:defRPr sz="1100" b="0">
+                <a:solidFill>
+                  <a:srgbClr val="000000"/>
+                </a:solidFill>
+              </a:defRPr>
+            </a:pPr>
+          </a:p>
+        </p:txBody>
+      </p:sp>
+      <p:pic>
+        <p:nvPicPr>
+          <p:cNvPr id="10" name="Picture 9" descr="page_27_img_17.png"/>
+          <p:cNvPicPr>
+            <a:picLocks noChangeAspect="1"/>
+          </p:cNvPicPr>
+          <p:nvPr/>
+        </p:nvPicPr>
+        <p:blipFill>
+          <a:blip r:embed="rId4"/>
+          <a:stretch>
+            <a:fillRect/>
+          </a:stretch>
+        </p:blipFill>
+        <p:spPr>
+          <a:xfrm>
+            <a:off x="1423115" y="5120640"/>
+            <a:ext cx="811369" cy="914400"/>
+          </a:xfrm>
+          <a:prstGeom prst="rect">
+            <a:avLst/>
+          </a:prstGeom>
+        </p:spPr>
+      </p:pic>
+      <p:sp>
+        <p:nvSpPr>
+          <p:cNvPr id="11" name="TextBox 10"/>
+          <p:cNvSpPr txBox="1"/>
+          <p:nvPr/>
+        </p:nvSpPr>
+        <p:spPr>
+          <a:xfrm>
+            <a:off x="457200" y="6035040"/>
+            <a:ext cx="2743200" cy="329184"/>
+          </a:xfrm>
+          <a:prstGeom prst="rect">
+            <a:avLst/>
+          </a:prstGeom>
+          <a:noFill/>
+        </p:spPr>
+        <p:txBody>
+          <a:bodyPr wrap="square">
+            <a:spAutoFit/>
+          </a:bodyPr>
+          <a:lstStyle/>
+          <a:p>
+            <a:pPr algn="ctr">
+              <a:defRPr sz="1400" b="1">
+                <a:solidFill>
+                  <a:srgbClr val="000000"/>
+                </a:solidFill>
+              </a:defRPr>
+            </a:pPr>
+            <a:r>
+              <a:t>HP Comfort Grip Wireless Mouse</a:t>
+            </a:r>
+          </a:p>
+        </p:txBody>
+      </p:sp>
+      <p:sp>
+        <p:nvSpPr>
+          <p:cNvPr id="12" name="TextBox 11"/>
+          <p:cNvSpPr txBox="1"/>
+          <p:nvPr/>
+        </p:nvSpPr>
+        <p:spPr>
+          <a:xfrm>
+            <a:off x="457200" y="6364224"/>
+            <a:ext cx="2743200" cy="585216"/>
+          </a:xfrm>
+          <a:prstGeom prst="rect">
+            <a:avLst/>
+          </a:prstGeom>
+          <a:noFill/>
+        </p:spPr>
+        <p:txBody>
+          <a:bodyPr wrap="square">
+            <a:spAutoFit/>
+          </a:bodyPr>
+          <a:lstStyle/>
+          <a:p>
+            <a:pPr algn="l">
+              <a:defRPr sz="1100" b="0">
+                <a:solidFill>
+                  <a:srgbClr val="000000"/>
+                </a:solidFill>
+              </a:defRPr>
+            </a:pPr>
+            <a:r>
+              <a:t>The HP Comfort Grip Wireless Mouse features a 30-month battery life de</a:t>
+            </a:r>
+          </a:p>
+        </p:txBody>
+      </p:sp>
+      <p:sp>
+        <p:nvSpPr>
+          <p:cNvPr id="13" name="TextBox 12"/>
+          <p:cNvSpPr txBox="1"/>
+          <p:nvPr/>
+        </p:nvSpPr>
+        <p:spPr>
+          <a:xfrm>
+            <a:off x="3200400" y="1097280"/>
+            <a:ext cx="2743200" cy="365760"/>
+          </a:xfrm>
+          <a:prstGeom prst="rect">
+            <a:avLst/>
+          </a:prstGeom>
+          <a:noFill/>
+        </p:spPr>
+        <p:txBody>
+          <a:bodyPr wrap="square">
+            <a:spAutoFit/>
+          </a:bodyPr>
+          <a:lstStyle/>
+          <a:p>
+            <a:pPr algn="ctr">
+              <a:defRPr sz="2200" b="1">
+                <a:solidFill>
+                  <a:srgbClr val="000000"/>
+                </a:solidFill>
+              </a:defRPr>
+            </a:pPr>
+            <a:r>
+              <a:t>Keyboard</a:t>
+            </a:r>
+          </a:p>
+        </p:txBody>
+      </p:sp>
+      <p:pic>
+        <p:nvPicPr>
+          <p:cNvPr id="14" name="Picture 13" descr="page_10_img_5.png"/>
+          <p:cNvPicPr>
+            <a:picLocks noChangeAspect="1"/>
+          </p:cNvPicPr>
+          <p:nvPr/>
+        </p:nvPicPr>
+        <p:blipFill>
+          <a:blip r:embed="rId5"/>
+          <a:stretch>
+            <a:fillRect/>
+          </a:stretch>
+        </p:blipFill>
+        <p:spPr>
+          <a:xfrm>
+            <a:off x="3749040" y="1463040"/>
+            <a:ext cx="1645920" cy="914400"/>
+          </a:xfrm>
+          <a:prstGeom prst="rect">
+            <a:avLst/>
+          </a:prstGeom>
+        </p:spPr>
+      </p:pic>
+      <p:sp>
+        <p:nvSpPr>
+          <p:cNvPr id="15" name="TextBox 14"/>
+          <p:cNvSpPr txBox="1"/>
+          <p:nvPr/>
+        </p:nvSpPr>
+        <p:spPr>
+          <a:xfrm>
+            <a:off x="3200400" y="2377440"/>
+            <a:ext cx="2743200" cy="329184"/>
+          </a:xfrm>
+          <a:prstGeom prst="rect">
+            <a:avLst/>
+          </a:prstGeom>
+          <a:noFill/>
+        </p:spPr>
+        <p:txBody>
+          <a:bodyPr wrap="square">
+            <a:spAutoFit/>
+          </a:bodyPr>
+          <a:lstStyle/>
+          <a:p>
+            <a:pPr algn="ctr">
+              <a:defRPr sz="1400" b="1">
+                <a:solidFill>
+                  <a:srgbClr val="000000"/>
+                </a:solidFill>
+              </a:defRPr>
+            </a:pPr>
+            <a:r>
+              <a:t>HP Slim Bluetooth Keyboard</a:t>
+            </a:r>
+          </a:p>
+        </p:txBody>
+      </p:sp>
+      <p:sp>
+        <p:nvSpPr>
+          <p:cNvPr id="16" name="TextBox 15"/>
+          <p:cNvSpPr txBox="1"/>
+          <p:nvPr/>
+        </p:nvSpPr>
+        <p:spPr>
+          <a:xfrm>
+            <a:off x="3200400" y="2706624"/>
+            <a:ext cx="2743200" cy="585216"/>
+          </a:xfrm>
+          <a:prstGeom prst="rect">
+            <a:avLst/>
+          </a:prstGeom>
+          <a:noFill/>
+        </p:spPr>
+        <p:txBody>
+          <a:bodyPr wrap="square">
+            <a:spAutoFit/>
+          </a:bodyPr>
+          <a:lstStyle/>
+          <a:p>
+            <a:pPr algn="l">
+              <a:defRPr sz="1100" b="0">
+                <a:solidFill>
+                  <a:srgbClr val="000000"/>
+                </a:solidFill>
+              </a:defRPr>
+            </a:pPr>
+            <a:r>
+              <a:t>The HP Slim Bluetooth Keyboard is a thin and light wireless keyboard t</a:t>
+            </a:r>
+          </a:p>
+        </p:txBody>
+      </p:sp>
+      <p:sp>
+        <p:nvSpPr>
+          <p:cNvPr id="17" name="TextBox 16"/>
+          <p:cNvSpPr txBox="1"/>
+          <p:nvPr/>
+        </p:nvSpPr>
+        <p:spPr>
+          <a:xfrm>
+            <a:off x="5943600" y="1097280"/>
+            <a:ext cx="2743200" cy="365760"/>
+          </a:xfrm>
+          <a:prstGeom prst="rect">
+            <a:avLst/>
+          </a:prstGeom>
+          <a:noFill/>
+        </p:spPr>
+        <p:txBody>
+          <a:bodyPr wrap="square">
+            <a:spAutoFit/>
+          </a:bodyPr>
+          <a:lstStyle/>
+          <a:p>
+            <a:pPr algn="ctr">
+              <a:defRPr sz="2200" b="1">
+                <a:solidFill>
+                  <a:srgbClr val="000000"/>
+                </a:solidFill>
+              </a:defRPr>
+            </a:pPr>
+            <a:r>
+              <a:t>Backpack</a:t>
+            </a:r>
+          </a:p>
+        </p:txBody>
+      </p:sp>
+      <p:pic>
+        <p:nvPicPr>
+          <p:cNvPr id="18" name="Picture 17" descr="page_28_img_15.png"/>
+          <p:cNvPicPr>
+            <a:picLocks noChangeAspect="1"/>
+          </p:cNvPicPr>
+          <p:nvPr/>
+        </p:nvPicPr>
+        <p:blipFill>
+          <a:blip r:embed="rId6"/>
+          <a:stretch>
+            <a:fillRect/>
+          </a:stretch>
+        </p:blipFill>
+        <p:spPr>
+          <a:xfrm>
+            <a:off x="6927640" y="1463040"/>
+            <a:ext cx="775120" cy="914400"/>
+          </a:xfrm>
+          <a:prstGeom prst="rect">
+            <a:avLst/>
+          </a:prstGeom>
+        </p:spPr>
+      </p:pic>
+      <p:sp>
+        <p:nvSpPr>
+          <p:cNvPr id="19" name="TextBox 18"/>
+          <p:cNvSpPr txBox="1"/>
+          <p:nvPr/>
+        </p:nvSpPr>
+        <p:spPr>
+          <a:xfrm>
+            <a:off x="5943600" y="2377440"/>
+            <a:ext cx="2743200" cy="329184"/>
+          </a:xfrm>
+          <a:prstGeom prst="rect">
+            <a:avLst/>
+          </a:prstGeom>
+          <a:noFill/>
+        </p:spPr>
+        <p:txBody>
+          <a:bodyPr wrap="square">
+            <a:spAutoFit/>
+          </a:bodyPr>
+          <a:lstStyle/>
+          <a:p>
+            <a:pPr algn="ctr">
+              <a:defRPr sz="1400" b="1">
+                <a:solidFill>
+                  <a:srgbClr val="000000"/>
+                </a:solidFill>
+              </a:defRPr>
+            </a:pPr>
+            <a:r>
+              <a:t>HP Business Nylon Backpack</a:t>
+            </a:r>
+          </a:p>
+        </p:txBody>
+      </p:sp>
+      <p:sp>
+        <p:nvSpPr>
+          <p:cNvPr id="20" name="TextBox 19"/>
+          <p:cNvSpPr txBox="1"/>
+          <p:nvPr/>
+        </p:nvSpPr>
+        <p:spPr>
+          <a:xfrm>
+            <a:off x="5943600" y="2706624"/>
+            <a:ext cx="2743200" cy="585216"/>
+          </a:xfrm>
+          <a:prstGeom prst="rect">
+            <a:avLst/>
+          </a:prstGeom>
+          <a:noFill/>
+        </p:spPr>
+        <p:txBody>
+          <a:bodyPr wrap="square">
+            <a:spAutoFit/>
+          </a:bodyPr>
+          <a:lstStyle/>
+          <a:p>
+            <a:pPr algn="l">
+              <a:defRPr sz="1100" b="0">
+                <a:solidFill>
+                  <a:srgbClr val="000000"/>
+                </a:solidFill>
+              </a:defRPr>
+            </a:pPr>
+            <a:r>
+              <a:t>HP Business Nylon Backpack offers a sturdy, all-purpose backpack for m</a:t>
+            </a:r>
+          </a:p>
+        </p:txBody>
+      </p:sp>
+      <p:pic>
+        <p:nvPicPr>
+          <p:cNvPr id="21" name="Picture 20" descr="page_28_img_6.png"/>
+          <p:cNvPicPr>
+            <a:picLocks noChangeAspect="1"/>
+          </p:cNvPicPr>
+          <p:nvPr/>
+        </p:nvPicPr>
+        <p:blipFill>
+          <a:blip r:embed="rId7"/>
+          <a:stretch>
+            <a:fillRect/>
+          </a:stretch>
+        </p:blipFill>
+        <p:spPr>
+          <a:xfrm>
+            <a:off x="6969125" y="3291840"/>
+            <a:ext cx="692150" cy="914400"/>
+          </a:xfrm>
+          <a:prstGeom prst="rect">
+            <a:avLst/>
+          </a:prstGeom>
+        </p:spPr>
+      </p:pic>
+      <p:sp>
+        <p:nvSpPr>
+          <p:cNvPr id="22" name="TextBox 21"/>
+          <p:cNvSpPr txBox="1"/>
+          <p:nvPr/>
+        </p:nvSpPr>
+        <p:spPr>
+          <a:xfrm>
+            <a:off x="5943600" y="4206240"/>
+            <a:ext cx="2743200" cy="329184"/>
+          </a:xfrm>
+          <a:prstGeom prst="rect">
+            <a:avLst/>
+          </a:prstGeom>
+          <a:noFill/>
+        </p:spPr>
+        <p:txBody>
+          <a:bodyPr wrap="square">
+            <a:spAutoFit/>
+          </a:bodyPr>
+          <a:lstStyle/>
+          <a:p>
+            <a:pPr algn="ctr">
+              <a:defRPr sz="1400" b="1">
+                <a:solidFill>
+                  <a:srgbClr val="000000"/>
+                </a:solidFill>
+              </a:defRPr>
+            </a:pPr>
+            <a:r>
+              <a:t>HP Essential Backpack</a:t>
+            </a:r>
+          </a:p>
+        </p:txBody>
+      </p:sp>
+      <p:sp>
+        <p:nvSpPr>
+          <p:cNvPr id="23" name="TextBox 22"/>
+          <p:cNvSpPr txBox="1"/>
+          <p:nvPr/>
+        </p:nvSpPr>
+        <p:spPr>
+          <a:xfrm>
+            <a:off x="5943600" y="4535424"/>
+            <a:ext cx="2743200" cy="585216"/>
+          </a:xfrm>
+          <a:prstGeom prst="rect">
+            <a:avLst/>
+          </a:prstGeom>
+          <a:noFill/>
+        </p:spPr>
+        <p:txBody>
+          <a:bodyPr wrap="square">
+            <a:spAutoFit/>
+          </a:bodyPr>
+          <a:lstStyle/>
+          <a:p>
+            <a:pPr algn="l">
+              <a:defRPr sz="1100" b="0">
+                <a:solidFill>
+                  <a:srgbClr val="000000"/>
+                </a:solidFill>
+              </a:defRPr>
+            </a:pPr>
+            <a:r>
+              <a:t>The HP Essential Backpack is a great notebook carrying solution for bo</a:t>
             </a:r>
           </a:p>
         </p:txBody>

</xml_diff>